<commit_message>
Updating the ssh key section to reflect what we actually did in class
</commit_message>
<xml_diff>
--- a/UNIX_session_1/Intro_to_Ada.pptx
+++ b/UNIX_session_1/Intro_to_Ada.pptx
@@ -335,6 +335,13 @@
           </p:nvPr>
         </p:nvSpPr>
         <p:spPr/>
+        <p:txBody>
+          <a:bodyPr/>
+          <a:lstStyle/>
+          <a:p>
+            <a:endParaRPr lang="en-US"/>
+          </a:p>
+        </p:txBody>
       </p:sp>
       <p:sp>
         <p:nvSpPr>
@@ -430,6 +437,13 @@
           </p:nvPr>
         </p:nvSpPr>
         <p:spPr/>
+        <p:txBody>
+          <a:bodyPr/>
+          <a:lstStyle/>
+          <a:p>
+            <a:endParaRPr lang="en-US"/>
+          </a:p>
+        </p:txBody>
       </p:sp>
       <p:sp>
         <p:nvSpPr>
@@ -512,6 +526,13 @@
           </p:nvPr>
         </p:nvSpPr>
         <p:spPr/>
+        <p:txBody>
+          <a:bodyPr/>
+          <a:lstStyle/>
+          <a:p>
+            <a:endParaRPr lang="en-US"/>
+          </a:p>
+        </p:txBody>
       </p:sp>
       <p:sp>
         <p:nvSpPr>
@@ -599,6 +620,13 @@
           </p:nvPr>
         </p:nvSpPr>
         <p:spPr/>
+        <p:txBody>
+          <a:bodyPr/>
+          <a:lstStyle/>
+          <a:p>
+            <a:endParaRPr lang="en-US"/>
+          </a:p>
+        </p:txBody>
       </p:sp>
       <p:sp>
         <p:nvSpPr>
@@ -674,6 +702,13 @@
           </p:nvPr>
         </p:nvSpPr>
         <p:spPr/>
+        <p:txBody>
+          <a:bodyPr/>
+          <a:lstStyle/>
+          <a:p>
+            <a:endParaRPr lang="en-US"/>
+          </a:p>
+        </p:txBody>
       </p:sp>
       <p:sp>
         <p:nvSpPr>
@@ -749,6 +784,13 @@
           </p:nvPr>
         </p:nvSpPr>
         <p:spPr/>
+        <p:txBody>
+          <a:bodyPr/>
+          <a:lstStyle/>
+          <a:p>
+            <a:endParaRPr lang="en-US"/>
+          </a:p>
+        </p:txBody>
       </p:sp>
       <p:sp>
         <p:nvSpPr>
@@ -824,6 +866,13 @@
           </p:nvPr>
         </p:nvSpPr>
         <p:spPr/>
+        <p:txBody>
+          <a:bodyPr/>
+          <a:lstStyle/>
+          <a:p>
+            <a:endParaRPr lang="en-US"/>
+          </a:p>
+        </p:txBody>
       </p:sp>
       <p:sp>
         <p:nvSpPr>
@@ -899,6 +948,13 @@
           </p:nvPr>
         </p:nvSpPr>
         <p:spPr/>
+        <p:txBody>
+          <a:bodyPr/>
+          <a:lstStyle/>
+          <a:p>
+            <a:endParaRPr lang="en-US"/>
+          </a:p>
+        </p:txBody>
       </p:sp>
       <p:sp>
         <p:nvSpPr>
@@ -981,6 +1037,13 @@
           </p:nvPr>
         </p:nvSpPr>
         <p:spPr/>
+        <p:txBody>
+          <a:bodyPr/>
+          <a:lstStyle/>
+          <a:p>
+            <a:endParaRPr lang="en-US"/>
+          </a:p>
+        </p:txBody>
       </p:sp>
       <p:sp>
         <p:nvSpPr>
@@ -1056,6 +1119,13 @@
           </p:nvPr>
         </p:nvSpPr>
         <p:spPr/>
+        <p:txBody>
+          <a:bodyPr/>
+          <a:lstStyle/>
+          <a:p>
+            <a:endParaRPr lang="en-US"/>
+          </a:p>
+        </p:txBody>
       </p:sp>
       <p:sp>
         <p:nvSpPr>
@@ -1138,6 +1208,13 @@
           </p:nvPr>
         </p:nvSpPr>
         <p:spPr/>
+        <p:txBody>
+          <a:bodyPr/>
+          <a:lstStyle/>
+          <a:p>
+            <a:endParaRPr lang="en-US"/>
+          </a:p>
+        </p:txBody>
       </p:sp>
       <p:sp>
         <p:nvSpPr>
@@ -1213,6 +1290,13 @@
           </p:nvPr>
         </p:nvSpPr>
         <p:spPr/>
+        <p:txBody>
+          <a:bodyPr/>
+          <a:lstStyle/>
+          <a:p>
+            <a:endParaRPr lang="en-US"/>
+          </a:p>
+        </p:txBody>
       </p:sp>
       <p:sp>
         <p:nvSpPr>
@@ -1288,6 +1372,13 @@
           </p:nvPr>
         </p:nvSpPr>
         <p:spPr/>
+        <p:txBody>
+          <a:bodyPr/>
+          <a:lstStyle/>
+          <a:p>
+            <a:endParaRPr lang="en-US"/>
+          </a:p>
+        </p:txBody>
       </p:sp>
       <p:sp>
         <p:nvSpPr>
@@ -1370,6 +1461,13 @@
           </p:nvPr>
         </p:nvSpPr>
         <p:spPr/>
+        <p:txBody>
+          <a:bodyPr/>
+          <a:lstStyle/>
+          <a:p>
+            <a:endParaRPr lang="en-US"/>
+          </a:p>
+        </p:txBody>
       </p:sp>
       <p:sp>
         <p:nvSpPr>
@@ -1445,6 +1543,13 @@
           </p:nvPr>
         </p:nvSpPr>
         <p:spPr/>
+        <p:txBody>
+          <a:bodyPr/>
+          <a:lstStyle/>
+          <a:p>
+            <a:endParaRPr lang="en-US"/>
+          </a:p>
+        </p:txBody>
       </p:sp>
       <p:sp>
         <p:nvSpPr>
@@ -1520,6 +1625,13 @@
           </p:nvPr>
         </p:nvSpPr>
         <p:spPr/>
+        <p:txBody>
+          <a:bodyPr/>
+          <a:lstStyle/>
+          <a:p>
+            <a:endParaRPr lang="en-US"/>
+          </a:p>
+        </p:txBody>
       </p:sp>
       <p:sp>
         <p:nvSpPr>
@@ -1602,6 +1714,13 @@
           </p:nvPr>
         </p:nvSpPr>
         <p:spPr/>
+        <p:txBody>
+          <a:bodyPr/>
+          <a:lstStyle/>
+          <a:p>
+            <a:endParaRPr lang="en-US"/>
+          </a:p>
+        </p:txBody>
       </p:sp>
       <p:sp>
         <p:nvSpPr>
@@ -1691,6 +1810,13 @@
           </p:nvPr>
         </p:nvSpPr>
         <p:spPr/>
+        <p:txBody>
+          <a:bodyPr/>
+          <a:lstStyle/>
+          <a:p>
+            <a:endParaRPr lang="en-US"/>
+          </a:p>
+        </p:txBody>
       </p:sp>
       <p:sp>
         <p:nvSpPr>
@@ -1766,6 +1892,13 @@
           </p:nvPr>
         </p:nvSpPr>
         <p:spPr/>
+        <p:txBody>
+          <a:bodyPr/>
+          <a:lstStyle/>
+          <a:p>
+            <a:endParaRPr lang="en-US"/>
+          </a:p>
+        </p:txBody>
       </p:sp>
       <p:sp>
         <p:nvSpPr>
@@ -1841,6 +1974,13 @@
           </p:nvPr>
         </p:nvSpPr>
         <p:spPr/>
+        <p:txBody>
+          <a:bodyPr/>
+          <a:lstStyle/>
+          <a:p>
+            <a:endParaRPr lang="en-US"/>
+          </a:p>
+        </p:txBody>
       </p:sp>
       <p:sp>
         <p:nvSpPr>
@@ -1916,6 +2056,13 @@
           </p:nvPr>
         </p:nvSpPr>
         <p:spPr/>
+        <p:txBody>
+          <a:bodyPr/>
+          <a:lstStyle/>
+          <a:p>
+            <a:endParaRPr lang="en-US"/>
+          </a:p>
+        </p:txBody>
       </p:sp>
       <p:sp>
         <p:nvSpPr>
@@ -1991,6 +2138,13 @@
           </p:nvPr>
         </p:nvSpPr>
         <p:spPr/>
+        <p:txBody>
+          <a:bodyPr/>
+          <a:lstStyle/>
+          <a:p>
+            <a:endParaRPr lang="en-US"/>
+          </a:p>
+        </p:txBody>
       </p:sp>
       <p:sp>
         <p:nvSpPr>
@@ -2183,7 +2337,7 @@
           <a:lstStyle/>
           <a:p>
             <a:fld id="{B70B061E-8F2F-D342-BB88-8B219BD1F6BB}" type="datetimeFigureOut">
-              <a:t>9/23/26</a:t>
+              <a:t>10/5/26</a:t>
             </a:fld>
             <a:endParaRPr/>
           </a:p>
@@ -2378,7 +2532,7 @@
           <a:lstStyle/>
           <a:p>
             <a:fld id="{B70B061E-8F2F-D342-BB88-8B219BD1F6BB}" type="datetimeFigureOut">
-              <a:t>9/23/26</a:t>
+              <a:t>10/5/26</a:t>
             </a:fld>
             <a:endParaRPr/>
           </a:p>
@@ -2583,7 +2737,7 @@
           <a:lstStyle/>
           <a:p>
             <a:fld id="{B70B061E-8F2F-D342-BB88-8B219BD1F6BB}" type="datetimeFigureOut">
-              <a:t>9/23/26</a:t>
+              <a:t>10/5/26</a:t>
             </a:fld>
             <a:endParaRPr/>
           </a:p>
@@ -2778,7 +2932,7 @@
           <a:lstStyle/>
           <a:p>
             <a:fld id="{B70B061E-8F2F-D342-BB88-8B219BD1F6BB}" type="datetimeFigureOut">
-              <a:t>9/23/26</a:t>
+              <a:t>10/5/26</a:t>
             </a:fld>
             <a:endParaRPr/>
           </a:p>
@@ -3047,7 +3201,7 @@
           <a:lstStyle/>
           <a:p>
             <a:fld id="{B70B061E-8F2F-D342-BB88-8B219BD1F6BB}" type="datetimeFigureOut">
-              <a:t>9/23/26</a:t>
+              <a:t>10/5/26</a:t>
             </a:fld>
             <a:endParaRPr/>
           </a:p>
@@ -3314,7 +3468,7 @@
           <a:lstStyle/>
           <a:p>
             <a:fld id="{B70B061E-8F2F-D342-BB88-8B219BD1F6BB}" type="datetimeFigureOut">
-              <a:t>9/23/26</a:t>
+              <a:t>10/5/26</a:t>
             </a:fld>
             <a:endParaRPr/>
           </a:p>
@@ -3730,7 +3884,7 @@
           <a:lstStyle/>
           <a:p>
             <a:fld id="{B70B061E-8F2F-D342-BB88-8B219BD1F6BB}" type="datetimeFigureOut">
-              <a:t>9/23/26</a:t>
+              <a:t>10/5/26</a:t>
             </a:fld>
             <a:endParaRPr/>
           </a:p>
@@ -3863,7 +4017,7 @@
           <a:lstStyle/>
           <a:p>
             <a:fld id="{B70B061E-8F2F-D342-BB88-8B219BD1F6BB}" type="datetimeFigureOut">
-              <a:t>9/23/26</a:t>
+              <a:t>10/5/26</a:t>
             </a:fld>
             <a:endParaRPr/>
           </a:p>
@@ -3969,7 +4123,7 @@
           <a:lstStyle/>
           <a:p>
             <a:fld id="{B70B061E-8F2F-D342-BB88-8B219BD1F6BB}" type="datetimeFigureOut">
-              <a:t>9/23/26</a:t>
+              <a:t>10/5/26</a:t>
             </a:fld>
             <a:endParaRPr/>
           </a:p>
@@ -4288,7 +4442,7 @@
           <a:lstStyle/>
           <a:p>
             <a:fld id="{B70B061E-8F2F-D342-BB88-8B219BD1F6BB}" type="datetimeFigureOut">
-              <a:t>9/23/26</a:t>
+              <a:t>10/5/26</a:t>
             </a:fld>
             <a:endParaRPr/>
           </a:p>
@@ -4570,7 +4724,7 @@
           <a:lstStyle/>
           <a:p>
             <a:fld id="{B70B061E-8F2F-D342-BB88-8B219BD1F6BB}" type="datetimeFigureOut">
-              <a:t>9/23/26</a:t>
+              <a:t>10/5/26</a:t>
             </a:fld>
             <a:endParaRPr/>
           </a:p>
@@ -4809,7 +4963,7 @@
           </a:lstStyle>
           <a:p>
             <a:fld id="{B70B061E-8F2F-D342-BB88-8B219BD1F6BB}" type="datetimeFigureOut">
-              <a:t>9/23/26</a:t>
+              <a:t>10/5/26</a:t>
             </a:fld>
             <a:endParaRPr/>
           </a:p>
@@ -6796,7 +6950,7 @@
         </p:spPr>
         <p:txBody>
           <a:bodyPr>
-            <a:normAutofit fontScale="94375"/>
+            <a:normAutofit fontScale="90000"/>
           </a:bodyPr>
           <a:lstStyle/>
           <a:p>
@@ -7916,7 +8070,7 @@
         </p:spPr>
         <p:txBody>
           <a:bodyPr>
-            <a:normAutofit fontScale="94375"/>
+            <a:normAutofit fontScale="90000"/>
           </a:bodyPr>
           <a:lstStyle/>
           <a:p>
@@ -8003,8 +8157,8 @@
         </p:nvSpPr>
         <p:spPr>
           <a:xfrm>
-            <a:off x="752433" y="1248462"/>
-            <a:ext cx="10687133" cy="1785104"/>
+            <a:off x="1717635" y="1248462"/>
+            <a:ext cx="9721931" cy="1785104"/>
           </a:xfrm>
           <a:prstGeom prst="rect">
             <a:avLst/>
@@ -8025,7 +8179,7 @@
               <a:buChar char="•"/>
             </a:pPr>
             <a:r>
-              <a:rPr sz="2000"/>
+              <a:rPr sz="2000" dirty="0"/>
               <a:t>SSH key pairs allow key-based login to a remote machine</a:t>
             </a:r>
           </a:p>
@@ -8038,7 +8192,7 @@
               <a:buChar char="•"/>
             </a:pPr>
             <a:r>
-              <a:rPr sz="2000"/>
+              <a:rPr sz="2000" dirty="0"/>
               <a:t>Keep your private key only on your own device and never share it</a:t>
             </a:r>
           </a:p>
@@ -8051,9 +8205,10 @@
               <a:buChar char="•"/>
             </a:pPr>
             <a:r>
-              <a:rPr sz="2000"/>
+              <a:rPr sz="2000" dirty="0"/>
               <a:t>Copy only the public key to a host you are authorised to use</a:t>
             </a:r>
+            <a:endParaRPr lang="en-GB" sz="2000" dirty="0"/>
           </a:p>
           <a:p>
             <a:pPr marL="285750" indent="-285750">
@@ -8064,9 +8219,10 @@
               <a:buChar char="•"/>
             </a:pPr>
             <a:r>
-              <a:rPr sz="2000"/>
-              <a:t>Protect the private key with a passphrase and follow University guidance</a:t>
-            </a:r>
+              <a:rPr lang="en-GB" sz="2000" dirty="0"/>
+              <a:t>Allow you to login without typing your password</a:t>
+            </a:r>
+            <a:endParaRPr sz="2000" dirty="0"/>
           </a:p>
         </p:txBody>
       </p:sp>
@@ -8299,7 +8455,7 @@
         </p:spPr>
         <p:txBody>
           <a:bodyPr>
-            <a:normAutofit fontScale="94375"/>
+            <a:normAutofit fontScale="90000"/>
           </a:bodyPr>
           <a:lstStyle/>
           <a:p>
@@ -8390,7 +8546,27 @@
                   </a:schemeClr>
                 </a:solidFill>
               </a:rPr>
-              <a:t>Create an Ed25519 key pair. Accept the default file location and set a memorable passphrase:</a:t>
+              <a:t>Create an Ed25519 key pair. Accept the default file location and </a:t>
+            </a:r>
+            <a:r>
+              <a:rPr lang="en-GB" dirty="0">
+                <a:solidFill>
+                  <a:schemeClr val="bg2">
+                    <a:lumMod val="50000"/>
+                  </a:schemeClr>
+                </a:solidFill>
+              </a:rPr>
+              <a:t>leave the passphrase blank</a:t>
+            </a:r>
+            <a:r>
+              <a:rPr dirty="0">
+                <a:solidFill>
+                  <a:schemeClr val="bg2">
+                    <a:lumMod val="50000"/>
+                  </a:schemeClr>
+                </a:solidFill>
+              </a:rPr>
+              <a:t>:</a:t>
             </a:r>
           </a:p>
           <a:p>
@@ -8511,7 +8687,27 @@
                   </a:schemeClr>
                 </a:solidFill>
               </a:rPr>
-              <a:t>Test the connection. You should enter the key passphrase, not the Ada password:</a:t>
+              <a:t>Test the connection. You should </a:t>
+            </a:r>
+            <a:r>
+              <a:rPr lang="en-GB" dirty="0">
+                <a:solidFill>
+                  <a:schemeClr val="bg2">
+                    <a:lumMod val="50000"/>
+                  </a:schemeClr>
+                </a:solidFill>
+              </a:rPr>
+              <a:t>not need to enter your password this time</a:t>
+            </a:r>
+            <a:r>
+              <a:rPr dirty="0">
+                <a:solidFill>
+                  <a:schemeClr val="bg2">
+                    <a:lumMod val="50000"/>
+                  </a:schemeClr>
+                </a:solidFill>
+              </a:rPr>
+              <a:t>:</a:t>
             </a:r>
           </a:p>
           <a:p>
@@ -10097,7 +10293,7 @@
         </p:spPr>
         <p:txBody>
           <a:bodyPr>
-            <a:normAutofit fontScale="94375"/>
+            <a:normAutofit fontScale="90000"/>
           </a:bodyPr>
           <a:lstStyle/>
           <a:p>

</xml_diff>